<commit_message>
v1.11.7: Edge Add-ons guide + full docs refresh for the 1.11 arc
EDGE_LISTING.md (submission checklist, permission justifications, Edge
listing copy — package is Edge-ready as-is). README + STORE_LISTING cover
all new modules and refreshed stats. All 6 Office docs regenerated with the
14-module map, new training chapter, spec rows, v1.11.7 stamps.

Co-Authored-By: Claude Opus 4.8 (1M context) <noreply@anthropic.com>
</commit_message>
<xml_diff>
--- a/docs/Colvio_Walkthrough.pptx
+++ b/docs/Colvio_Walkthrough.pptx
@@ -2024,7 +2024,7 @@
                 <a:ea typeface="Calibri" pitchFamily="34" charset="-122"/>
                 <a:cs typeface="Calibri" pitchFamily="34" charset="-120"/>
               </a:rPr>
-              <a:t>Product walkthrough  ·  v1.10.26  ·  June 2026</a:t>
+              <a:t>Product walkthrough  ·  v1.11.7  ·  June 2026</a:t>
             </a:r>
             <a:endParaRPr lang="en-US" sz="1100" dirty="0"/>
           </a:p>
@@ -2193,7 +2193,7 @@
                 <a:ea typeface="Calibri" pitchFamily="34" charset="-122"/>
                 <a:cs typeface="Calibri" pitchFamily="34" charset="-120"/>
               </a:rPr>
-              <a:t>Colvio  ·  v1.10.26</a:t>
+              <a:t>Colvio  ·  v1.11.7</a:t>
             </a:r>
             <a:endParaRPr lang="en-US" sz="850" dirty="0"/>
           </a:p>
@@ -2492,7 +2492,7 @@
                 <a:ea typeface="Calibri" pitchFamily="34" charset="-122"/>
                 <a:cs typeface="Calibri" pitchFamily="34" charset="-120"/>
               </a:rPr>
-              <a:t>Colvio  ·  v1.10.26</a:t>
+              <a:t>Colvio  ·  v1.11.7</a:t>
             </a:r>
             <a:endParaRPr lang="en-US" sz="850" dirty="0"/>
           </a:p>
@@ -3379,7 +3379,7 @@
                 <a:ea typeface="Calibri" pitchFamily="34" charset="-122"/>
                 <a:cs typeface="Calibri" pitchFamily="34" charset="-120"/>
               </a:rPr>
-              <a:t>Colvio  ·  v1.10.26</a:t>
+              <a:t>Colvio  ·  v1.11.7</a:t>
             </a:r>
             <a:endParaRPr lang="en-US" sz="850" dirty="0"/>
           </a:p>
@@ -3552,7 +3552,7 @@
                 <a:ea typeface="Trebuchet MS" pitchFamily="34" charset="-122"/>
                 <a:cs typeface="Trebuchet MS" pitchFamily="34" charset="-120"/>
               </a:rPr>
-              <a:t>12</a:t>
+              <a:t>14</a:t>
             </a:r>
             <a:endParaRPr lang="en-US" sz="4400" dirty="0"/>
           </a:p>
@@ -3608,7 +3608,7 @@
                 <a:ea typeface="Calibri" pitchFamily="34" charset="-122"/>
                 <a:cs typeface="Calibri" pitchFamily="34" charset="-120"/>
               </a:rPr>
-              <a:t>to bulk loader to security audit</a:t>
+              <a:t>to recycle bin to security audit</a:t>
             </a:r>
             <a:endParaRPr lang="en-US" sz="1200" dirty="0"/>
           </a:p>
@@ -3872,7 +3872,7 @@
                 <a:ea typeface="Trebuchet MS" pitchFamily="34" charset="-122"/>
                 <a:cs typeface="Trebuchet MS" pitchFamily="34" charset="-120"/>
               </a:rPr>
-              <a:t>One panel, twelve modules</a:t>
+              <a:t>One panel, fourteen modules</a:t>
             </a:r>
             <a:endParaRPr lang="en-US" sz="2700" dirty="0"/>
           </a:p>
@@ -3911,7 +3911,7 @@
                 <a:ea typeface="Calibri" pitchFamily="34" charset="-122"/>
                 <a:cs typeface="Calibri" pitchFamily="34" charset="-120"/>
               </a:rPr>
-              <a:t>Colvio  ·  v1.10.26</a:t>
+              <a:t>Colvio  ·  v1.11.7</a:t>
             </a:r>
             <a:endParaRPr lang="en-US" sz="850" dirty="0"/>
           </a:p>
@@ -3934,7 +3934,7 @@
         <p:spPr>
           <a:xfrm>
             <a:off x="1097280" y="1188720"/>
-            <a:ext cx="6949440" cy="3563927"/>
+            <a:ext cx="6949440" cy="3959919"/>
           </a:xfrm>
           <a:prstGeom prst="rect">
             <a:avLst/>
@@ -4104,7 +4104,7 @@
                 <a:ea typeface="Calibri" pitchFamily="34" charset="-122"/>
                 <a:cs typeface="Calibri" pitchFamily="34" charset="-120"/>
               </a:rPr>
-              <a:t>Colvio  ·  v1.10.26</a:t>
+              <a:t>Colvio  ·  v1.11.7</a:t>
             </a:r>
             <a:endParaRPr lang="en-US" sz="850" dirty="0"/>
           </a:p>
@@ -4403,7 +4403,7 @@
                 <a:ea typeface="Calibri" pitchFamily="34" charset="-122"/>
                 <a:cs typeface="Calibri" pitchFamily="34" charset="-120"/>
               </a:rPr>
-              <a:t>Colvio  ·  v1.10.26</a:t>
+              <a:t>Colvio  ·  v1.11.7</a:t>
             </a:r>
             <a:endParaRPr lang="en-US" sz="850" dirty="0"/>
           </a:p>
@@ -5044,7 +5044,7 @@
                 <a:ea typeface="Calibri" pitchFamily="34" charset="-122"/>
                 <a:cs typeface="Calibri" pitchFamily="34" charset="-120"/>
               </a:rPr>
-              <a:t>Colvio  ·  v1.10.26</a:t>
+              <a:t>Colvio  ·  v1.11.7</a:t>
             </a:r>
             <a:endParaRPr lang="en-US" sz="850" dirty="0"/>
           </a:p>
@@ -5504,7 +5504,7 @@
                 <a:ea typeface="Calibri" pitchFamily="34" charset="-122"/>
                 <a:cs typeface="Calibri" pitchFamily="34" charset="-120"/>
               </a:rPr>
-              <a:t>Colvio  ·  v1.10.26</a:t>
+              <a:t>Colvio  ·  v1.11.7</a:t>
             </a:r>
             <a:endParaRPr lang="en-US" sz="850" dirty="0"/>
           </a:p>
@@ -5761,7 +5761,7 @@
                 <a:ea typeface="Calibri" pitchFamily="34" charset="-122"/>
                 <a:cs typeface="Calibri" pitchFamily="34" charset="-120"/>
               </a:rPr>
-              <a:t>Colvio  ·  v1.10.26</a:t>
+              <a:t>Colvio  ·  v1.11.7</a:t>
             </a:r>
             <a:endParaRPr lang="en-US" sz="850" dirty="0"/>
           </a:p>
@@ -6141,7 +6141,7 @@
                 <a:ea typeface="Calibri" pitchFamily="34" charset="-122"/>
                 <a:cs typeface="Calibri" pitchFamily="34" charset="-120"/>
               </a:rPr>
-              <a:t>Colvio  ·  v1.10.26</a:t>
+              <a:t>Colvio  ·  v1.11.7</a:t>
             </a:r>
             <a:endParaRPr lang="en-US" sz="850" dirty="0"/>
           </a:p>

</xml_diff>

<commit_message>
v1.11.7: Edge guide + docs refresh (#41)
EDGE_LISTING.md (submission checklist, permission justifications, Edge
listing copy — package is Edge-ready as-is). README + STORE_LISTING cover
all new modules and refreshed stats. All 6 Office docs regenerated with the
14-module map, new training chapter, spec rows, v1.11.7 stamps.

Co-authored-by: Claude Opus 4.8 (1M context) <noreply@anthropic.com>
</commit_message>
<xml_diff>
--- a/docs/Colvio_Walkthrough.pptx
+++ b/docs/Colvio_Walkthrough.pptx
@@ -2024,7 +2024,7 @@
                 <a:ea typeface="Calibri" pitchFamily="34" charset="-122"/>
                 <a:cs typeface="Calibri" pitchFamily="34" charset="-120"/>
               </a:rPr>
-              <a:t>Product walkthrough  ·  v1.10.26  ·  June 2026</a:t>
+              <a:t>Product walkthrough  ·  v1.11.7  ·  June 2026</a:t>
             </a:r>
             <a:endParaRPr lang="en-US" sz="1100" dirty="0"/>
           </a:p>
@@ -2193,7 +2193,7 @@
                 <a:ea typeface="Calibri" pitchFamily="34" charset="-122"/>
                 <a:cs typeface="Calibri" pitchFamily="34" charset="-120"/>
               </a:rPr>
-              <a:t>Colvio  ·  v1.10.26</a:t>
+              <a:t>Colvio  ·  v1.11.7</a:t>
             </a:r>
             <a:endParaRPr lang="en-US" sz="850" dirty="0"/>
           </a:p>
@@ -2492,7 +2492,7 @@
                 <a:ea typeface="Calibri" pitchFamily="34" charset="-122"/>
                 <a:cs typeface="Calibri" pitchFamily="34" charset="-120"/>
               </a:rPr>
-              <a:t>Colvio  ·  v1.10.26</a:t>
+              <a:t>Colvio  ·  v1.11.7</a:t>
             </a:r>
             <a:endParaRPr lang="en-US" sz="850" dirty="0"/>
           </a:p>
@@ -3379,7 +3379,7 @@
                 <a:ea typeface="Calibri" pitchFamily="34" charset="-122"/>
                 <a:cs typeface="Calibri" pitchFamily="34" charset="-120"/>
               </a:rPr>
-              <a:t>Colvio  ·  v1.10.26</a:t>
+              <a:t>Colvio  ·  v1.11.7</a:t>
             </a:r>
             <a:endParaRPr lang="en-US" sz="850" dirty="0"/>
           </a:p>
@@ -3552,7 +3552,7 @@
                 <a:ea typeface="Trebuchet MS" pitchFamily="34" charset="-122"/>
                 <a:cs typeface="Trebuchet MS" pitchFamily="34" charset="-120"/>
               </a:rPr>
-              <a:t>12</a:t>
+              <a:t>14</a:t>
             </a:r>
             <a:endParaRPr lang="en-US" sz="4400" dirty="0"/>
           </a:p>
@@ -3608,7 +3608,7 @@
                 <a:ea typeface="Calibri" pitchFamily="34" charset="-122"/>
                 <a:cs typeface="Calibri" pitchFamily="34" charset="-120"/>
               </a:rPr>
-              <a:t>to bulk loader to security audit</a:t>
+              <a:t>to recycle bin to security audit</a:t>
             </a:r>
             <a:endParaRPr lang="en-US" sz="1200" dirty="0"/>
           </a:p>
@@ -3872,7 +3872,7 @@
                 <a:ea typeface="Trebuchet MS" pitchFamily="34" charset="-122"/>
                 <a:cs typeface="Trebuchet MS" pitchFamily="34" charset="-120"/>
               </a:rPr>
-              <a:t>One panel, twelve modules</a:t>
+              <a:t>One panel, fourteen modules</a:t>
             </a:r>
             <a:endParaRPr lang="en-US" sz="2700" dirty="0"/>
           </a:p>
@@ -3911,7 +3911,7 @@
                 <a:ea typeface="Calibri" pitchFamily="34" charset="-122"/>
                 <a:cs typeface="Calibri" pitchFamily="34" charset="-120"/>
               </a:rPr>
-              <a:t>Colvio  ·  v1.10.26</a:t>
+              <a:t>Colvio  ·  v1.11.7</a:t>
             </a:r>
             <a:endParaRPr lang="en-US" sz="850" dirty="0"/>
           </a:p>
@@ -3934,7 +3934,7 @@
         <p:spPr>
           <a:xfrm>
             <a:off x="1097280" y="1188720"/>
-            <a:ext cx="6949440" cy="3563927"/>
+            <a:ext cx="6949440" cy="3959919"/>
           </a:xfrm>
           <a:prstGeom prst="rect">
             <a:avLst/>
@@ -4104,7 +4104,7 @@
                 <a:ea typeface="Calibri" pitchFamily="34" charset="-122"/>
                 <a:cs typeface="Calibri" pitchFamily="34" charset="-120"/>
               </a:rPr>
-              <a:t>Colvio  ·  v1.10.26</a:t>
+              <a:t>Colvio  ·  v1.11.7</a:t>
             </a:r>
             <a:endParaRPr lang="en-US" sz="850" dirty="0"/>
           </a:p>
@@ -4403,7 +4403,7 @@
                 <a:ea typeface="Calibri" pitchFamily="34" charset="-122"/>
                 <a:cs typeface="Calibri" pitchFamily="34" charset="-120"/>
               </a:rPr>
-              <a:t>Colvio  ·  v1.10.26</a:t>
+              <a:t>Colvio  ·  v1.11.7</a:t>
             </a:r>
             <a:endParaRPr lang="en-US" sz="850" dirty="0"/>
           </a:p>
@@ -5044,7 +5044,7 @@
                 <a:ea typeface="Calibri" pitchFamily="34" charset="-122"/>
                 <a:cs typeface="Calibri" pitchFamily="34" charset="-120"/>
               </a:rPr>
-              <a:t>Colvio  ·  v1.10.26</a:t>
+              <a:t>Colvio  ·  v1.11.7</a:t>
             </a:r>
             <a:endParaRPr lang="en-US" sz="850" dirty="0"/>
           </a:p>
@@ -5504,7 +5504,7 @@
                 <a:ea typeface="Calibri" pitchFamily="34" charset="-122"/>
                 <a:cs typeface="Calibri" pitchFamily="34" charset="-120"/>
               </a:rPr>
-              <a:t>Colvio  ·  v1.10.26</a:t>
+              <a:t>Colvio  ·  v1.11.7</a:t>
             </a:r>
             <a:endParaRPr lang="en-US" sz="850" dirty="0"/>
           </a:p>
@@ -5761,7 +5761,7 @@
                 <a:ea typeface="Calibri" pitchFamily="34" charset="-122"/>
                 <a:cs typeface="Calibri" pitchFamily="34" charset="-120"/>
               </a:rPr>
-              <a:t>Colvio  ·  v1.10.26</a:t>
+              <a:t>Colvio  ·  v1.11.7</a:t>
             </a:r>
             <a:endParaRPr lang="en-US" sz="850" dirty="0"/>
           </a:p>
@@ -6141,7 +6141,7 @@
                 <a:ea typeface="Calibri" pitchFamily="34" charset="-122"/>
                 <a:cs typeface="Calibri" pitchFamily="34" charset="-120"/>
               </a:rPr>
-              <a:t>Colvio  ·  v1.10.26</a:t>
+              <a:t>Colvio  ·  v1.11.7</a:t>
             </a:r>
             <a:endParaRPr lang="en-US" sz="850" dirty="0"/>
           </a:p>

</xml_diff>